<commit_message>
Remove speaker notes from Grade 7 Past Perfect adventure PPT.
Co-authored-by: Cursor <cursoragent@cursor.com>
</commit_message>
<xml_diff>
--- a/Grade7_Past_Perfect_English_Adventure_60min.pptx
+++ b/Grade7_Past_Perfect_English_Adventure_60min.pptx
@@ -521,77 +521,7 @@
         <p:txBody>
           <a:bodyPr/>
           <a:lstStyle/>
-          <a:p>
-            <a:r>
-              <a:t>WHAT TO SAY:</a:t>
-            </a:r>
-          </a:p>
-          <a:p>
-            <a:r>
-              <a:t>Welcome warmly. Set playful tone: 'We are detectives and storytellers today.'</a:t>
-            </a:r>
-          </a:p>
           <a:p/>
-          <a:p>
-            <a:r>
-              <a:t>STUDENT ACTIVITY:</a:t>
-            </a:r>
-          </a:p>
-          <a:p>
-            <a:r>
-              <a:t>Share one word you hope to learn today.</a:t>
-            </a:r>
-          </a:p>
-          <a:p/>
-          <a:p>
-            <a:r>
-              <a:t>EXPECTED ANSWERS / RESPONSES:</a:t>
-            </a:r>
-          </a:p>
-          <a:p>
-            <a:r>
-              <a:t>Student names a skill/word; shows mood.</a:t>
-            </a:r>
-          </a:p>
-          <a:p/>
-          <a:p>
-            <a:r>
-              <a:t>COMMON MISTAKES:</a:t>
-            </a:r>
-          </a:p>
-          <a:p>
-            <a:r>
-              <a:t>Saying 'I don't know'—normalize trying.</a:t>
-            </a:r>
-          </a:p>
-          <a:p/>
-          <a:p>
-            <a:r>
-              <a:t>ASSESSMENT TIPS:</a:t>
-            </a:r>
-          </a:p>
-          <a:p>
-            <a:r>
-              <a:t>Confidence, engagement baseline.</a:t>
-            </a:r>
-          </a:p>
-          <a:p/>
-          <a:p>
-            <a:r>
-              <a:t>EXTENSION QUESTIONS:</a:t>
-            </a:r>
-          </a:p>
-          <a:p>
-            <a:r>
-              <a:t>What kind of adventure stories do you like?</a:t>
-            </a:r>
-          </a:p>
-          <a:p/>
-          <a:p>
-            <a:r>
-              <a:t>TIMING: 5 min</a:t>
-            </a:r>
-          </a:p>
         </p:txBody>
       </p:sp>
       <p:sp>
@@ -657,77 +587,7 @@
         <p:txBody>
           <a:bodyPr/>
           <a:lstStyle/>
-          <a:p>
-            <a:r>
-              <a:t>WHAT TO SAY:</a:t>
-            </a:r>
-          </a:p>
-          <a:p>
-            <a:r>
-              <a:t>Partner read or echo read.</a:t>
-            </a:r>
-          </a:p>
           <a:p/>
-          <a:p>
-            <a:r>
-              <a:t>STUDENT ACTIVITY:</a:t>
-            </a:r>
-          </a:p>
-          <a:p>
-            <a:r>
-              <a:t>Annotate + pronounce 5 words.</a:t>
-            </a:r>
-          </a:p>
-          <a:p/>
-          <a:p>
-            <a:r>
-              <a:t>EXPECTED ANSWERS / RESPONSES:</a:t>
-            </a:r>
-          </a:p>
-          <a:p>
-            <a:r>
-              <a:t>Find 4+ had ___ forms.</a:t>
-            </a:r>
-          </a:p>
-          <a:p/>
-          <a:p>
-            <a:r>
-              <a:t>COMMON MISTAKES:</a:t>
-            </a:r>
-          </a:p>
-          <a:p>
-            <a:r>
-              <a:t>Missing past participles.</a:t>
-            </a:r>
-          </a:p>
-          <a:p/>
-          <a:p>
-            <a:r>
-              <a:t>ASSESSMENT TIPS:</a:t>
-            </a:r>
-          </a:p>
-          <a:p>
-            <a:r>
-              <a:t>Close reading habits.</a:t>
-            </a:r>
-          </a:p>
-          <a:p/>
-          <a:p>
-            <a:r>
-              <a:t>EXTENSION QUESTIONS:</a:t>
-            </a:r>
-          </a:p>
-          <a:p>
-            <a:r>
-              <a:t>Which clue was most important?</a:t>
-            </a:r>
-          </a:p>
-          <a:p/>
-          <a:p>
-            <a:r>
-              <a:t>TIMING: Reading block</a:t>
-            </a:r>
-          </a:p>
         </p:txBody>
       </p:sp>
       <p:sp>
@@ -793,77 +653,7 @@
         <p:txBody>
           <a:bodyPr/>
           <a:lstStyle/>
-          <a:p>
-            <a:r>
-              <a:t>WHAT TO SAY:</a:t>
-            </a:r>
-          </a:p>
-          <a:p>
-            <a:r>
-              <a:t>One at a time; cite evidence.</a:t>
-            </a:r>
-          </a:p>
           <a:p/>
-          <a:p>
-            <a:r>
-              <a:t>STUDENT ACTIVITY:</a:t>
-            </a:r>
-          </a:p>
-          <a:p>
-            <a:r>
-              <a:t>Answer all 10.</a:t>
-            </a:r>
-          </a:p>
-          <a:p/>
-          <a:p>
-            <a:r>
-              <a:t>EXPECTED ANSWERS / RESPONSES:</a:t>
-            </a:r>
-          </a:p>
-          <a:p>
-            <a:r>
-              <a:t>1A 2B 3F 4T 5 Chapter One/Two note 6 secret library discovery 7 safety 8B 9 handle→map→lights 10 reasoned opinion</a:t>
-            </a:r>
-          </a:p>
-          <a:p/>
-          <a:p>
-            <a:r>
-              <a:t>COMMON MISTAKES:</a:t>
-            </a:r>
-          </a:p>
-          <a:p>
-            <a:r>
-              <a:t>Guessing.</a:t>
-            </a:r>
-          </a:p>
-          <a:p/>
-          <a:p>
-            <a:r>
-              <a:t>ASSESSMENT TIPS:</a:t>
-            </a:r>
-          </a:p>
-          <a:p>
-            <a:r>
-              <a:t>Comprehension depth.</a:t>
-            </a:r>
-          </a:p>
-          <a:p/>
-          <a:p>
-            <a:r>
-              <a:t>EXTENSION QUESTIONS:</a:t>
-            </a:r>
-          </a:p>
-          <a:p>
-            <a:r>
-              <a:t>Which past perfect sentence best supports #6?</a:t>
-            </a:r>
-          </a:p>
-          <a:p/>
-          <a:p>
-            <a:r>
-              <a:t>TIMING: Reading 10 min total</a:t>
-            </a:r>
-          </a:p>
         </p:txBody>
       </p:sp>
       <p:sp>
@@ -929,77 +719,7 @@
         <p:txBody>
           <a:bodyPr/>
           <a:lstStyle/>
-          <a:p>
-            <a:r>
-              <a:t>WHAT TO SAY:</a:t>
-            </a:r>
-          </a:p>
-          <a:p>
-            <a:r>
-              <a:t>Teach 6–10 words with repeat-back.</a:t>
-            </a:r>
-          </a:p>
           <a:p/>
-          <a:p>
-            <a:r>
-              <a:t>STUDENT ACTIVITY:</a:t>
-            </a:r>
-          </a:p>
-          <a:p>
-            <a:r>
-              <a:t>Say word + own sentence for 3 words.</a:t>
-            </a:r>
-          </a:p>
-          <a:p/>
-          <a:p>
-            <a:r>
-              <a:t>EXPECTED ANSWERS / RESPONSES:</a:t>
-            </a:r>
-          </a:p>
-          <a:p>
-            <a:r>
-              <a:t>Correct usage in sentences.</a:t>
-            </a:r>
-          </a:p>
-          <a:p/>
-          <a:p>
-            <a:r>
-              <a:t>COMMON MISTAKES:</a:t>
-            </a:r>
-          </a:p>
-          <a:p>
-            <a:r>
-              <a:t>Synonym confusion.</a:t>
-            </a:r>
-          </a:p>
-          <a:p/>
-          <a:p>
-            <a:r>
-              <a:t>ASSESSMENT TIPS:</a:t>
-            </a:r>
-          </a:p>
-          <a:p>
-            <a:r>
-              <a:t>Pronunciation + meaning.</a:t>
-            </a:r>
-          </a:p>
-          <a:p/>
-          <a:p>
-            <a:r>
-              <a:t>EXTENSION QUESTIONS:</a:t>
-            </a:r>
-          </a:p>
-          <a:p>
-            <a:r>
-              <a:t>Which word describes Riley's feeling?</a:t>
-            </a:r>
-          </a:p>
-          <a:p/>
-          <a:p>
-            <a:r>
-              <a:t>TIMING: 5 min vocab</a:t>
-            </a:r>
-          </a:p>
         </p:txBody>
       </p:sp>
       <p:sp>
@@ -1065,77 +785,7 @@
         <p:txBody>
           <a:bodyPr/>
           <a:lstStyle/>
-          <a:p>
-            <a:r>
-              <a:t>WHAT TO SAY:</a:t>
-            </a:r>
-          </a:p>
-          <a:p>
-            <a:r>
-              <a:t>Match 1–6 to letters.</a:t>
-            </a:r>
-          </a:p>
           <a:p/>
-          <a:p>
-            <a:r>
-              <a:t>STUDENT ACTIVITY:</a:t>
-            </a:r>
-          </a:p>
-          <a:p>
-            <a:r>
-              <a:t>Say matches aloud.</a:t>
-            </a:r>
-          </a:p>
-          <a:p/>
-          <a:p>
-            <a:r>
-              <a:t>EXPECTED ANSWERS / RESPONSES:</a:t>
-            </a:r>
-          </a:p>
-          <a:p>
-            <a:r>
-              <a:t>1-C biography  2-E parchment  3-A echoed/creaked  4-B curiosity  5-D flickered  6-F adventure</a:t>
-            </a:r>
-          </a:p>
-          <a:p/>
-          <a:p>
-            <a:r>
-              <a:t>COMMON MISTAKES:</a:t>
-            </a:r>
-          </a:p>
-          <a:p>
-            <a:r>
-              <a:t>Shuffled confusion.</a:t>
-            </a:r>
-          </a:p>
-          <a:p/>
-          <a:p>
-            <a:r>
-              <a:t>ASSESSMENT TIPS:</a:t>
-            </a:r>
-          </a:p>
-          <a:p>
-            <a:r>
-              <a:t>Matching skill.</a:t>
-            </a:r>
-          </a:p>
-          <a:p/>
-          <a:p>
-            <a:r>
-              <a:t>EXTENSION QUESTIONS:</a:t>
-            </a:r>
-          </a:p>
-          <a:p>
-            <a:r>
-              <a:t>Match remaining 4 words from slide 12.</a:t>
-            </a:r>
-          </a:p>
-          <a:p/>
-          <a:p>
-            <a:r>
-              <a:t>TIMING: Vocab game</a:t>
-            </a:r>
-          </a:p>
         </p:txBody>
       </p:sp>
       <p:sp>
@@ -1201,77 +851,7 @@
         <p:txBody>
           <a:bodyPr/>
           <a:lstStyle/>
-          <a:p>
-            <a:r>
-              <a:t>WHAT TO SAY:</a:t>
-            </a:r>
-          </a:p>
-          <a:p>
-            <a:r>
-              <a:t>3 min word search; 2 min unscramble.</a:t>
-            </a:r>
-          </a:p>
           <a:p/>
-          <a:p>
-            <a:r>
-              <a:t>STUDENT ACTIVITY:</a:t>
-            </a:r>
-          </a:p>
-          <a:p>
-            <a:r>
-              <a:t>Find SECRET, DOOR, LIBRARY, MOSS, MAP, ECHO; unscramble words.</a:t>
-            </a:r>
-          </a:p>
-          <a:p/>
-          <a:p>
-            <a:r>
-              <a:t>EXPECTED ANSWERS / RESPONSES:</a:t>
-            </a:r>
-          </a:p>
-          <a:p>
-            <a:r>
-              <a:t>See slide key.</a:t>
-            </a:r>
-          </a:p>
-          <a:p/>
-          <a:p>
-            <a:r>
-              <a:t>COMMON MISTAKES:</a:t>
-            </a:r>
-          </a:p>
-          <a:p>
-            <a:r>
-              <a:t>Spelling.</a:t>
-            </a:r>
-          </a:p>
-          <a:p/>
-          <a:p>
-            <a:r>
-              <a:t>ASSESSMENT TIPS:</a:t>
-            </a:r>
-          </a:p>
-          <a:p>
-            <a:r>
-              <a:t>Word recognition.</a:t>
-            </a:r>
-          </a:p>
-          <a:p/>
-          <a:p>
-            <a:r>
-              <a:t>EXTENSION QUESTIONS:</a:t>
-            </a:r>
-          </a:p>
-          <a:p>
-            <a:r>
-              <a:t>Use ECHO in past perfect sentence.</a:t>
-            </a:r>
-          </a:p>
-          <a:p/>
-          <a:p>
-            <a:r>
-              <a:t>TIMING: Vocab games</a:t>
-            </a:r>
-          </a:p>
         </p:txBody>
       </p:sp>
       <p:sp>
@@ -1337,77 +917,7 @@
         <p:txBody>
           <a:bodyPr/>
           <a:lstStyle/>
-          <a:p>
-            <a:r>
-              <a:t>WHAT TO SAY:</a:t>
-            </a:r>
-          </a:p>
-          <a:p>
-            <a:r>
-              <a:t>Student picks 2 activities.</a:t>
-            </a:r>
-          </a:p>
           <a:p/>
-          <a:p>
-            <a:r>
-              <a:t>STUDENT ACTIVITY:</a:t>
-            </a:r>
-          </a:p>
-          <a:p>
-            <a:r>
-              <a:t>Extended speaking with past perfect where possible.</a:t>
-            </a:r>
-          </a:p>
-          <a:p/>
-          <a:p>
-            <a:r>
-              <a:t>EXPECTED ANSWERS / RESPONSES:</a:t>
-            </a:r>
-          </a:p>
-          <a:p>
-            <a:r>
-              <a:t>Clear ideas; uses story vocabulary.</a:t>
-            </a:r>
-          </a:p>
-          <a:p/>
-          <a:p>
-            <a:r>
-              <a:t>COMMON MISTAKES:</a:t>
-            </a:r>
-          </a:p>
-          <a:p>
-            <a:r>
-              <a:t>Short answers—prompt 'tell me more'.</a:t>
-            </a:r>
-          </a:p>
-          <a:p/>
-          <a:p>
-            <a:r>
-              <a:t>ASSESSMENT TIPS:</a:t>
-            </a:r>
-          </a:p>
-          <a:p>
-            <a:r>
-              <a:t>Confidence + fluency.</a:t>
-            </a:r>
-          </a:p>
-          <a:p/>
-          <a:p>
-            <a:r>
-              <a:t>EXTENSION QUESTIONS:</a:t>
-            </a:r>
-          </a:p>
-          <a:p>
-            <a:r>
-              <a:t>Use one past perfect sentence in interview.</a:t>
-            </a:r>
-          </a:p>
-          <a:p/>
-          <a:p>
-            <a:r>
-              <a:t>TIMING: Speaking 10 min block</a:t>
-            </a:r>
-          </a:p>
         </p:txBody>
       </p:sp>
       <p:sp>
@@ -1473,77 +983,7 @@
         <p:txBody>
           <a:bodyPr/>
           <a:lstStyle/>
-          <a:p>
-            <a:r>
-              <a:t>WHAT TO SAY:</a:t>
-            </a:r>
-          </a:p>
-          <a:p>
-            <a:r>
-              <a:t>Plan 60 sec; then tell story.</a:t>
-            </a:r>
-          </a:p>
           <a:p/>
-          <a:p>
-            <a:r>
-              <a:t>STUDENT ACTIVITY:</a:t>
-            </a:r>
-          </a:p>
-          <a:p>
-            <a:r>
-              <a:t>5-part story from prompt.</a:t>
-            </a:r>
-          </a:p>
-          <a:p/>
-          <a:p>
-            <a:r>
-              <a:t>EXPECTED ANSWERS / RESPONSES:</a:t>
-            </a:r>
-          </a:p>
-          <a:p>
-            <a:r>
-              <a:t>Beginning/middle/end + lesson.</a:t>
-            </a:r>
-          </a:p>
-          <a:p/>
-          <a:p>
-            <a:r>
-              <a:t>COMMON MISTAKES:</a:t>
-            </a:r>
-          </a:p>
-          <a:p>
-            <a:r>
-              <a:t>Skipping problem/solution.</a:t>
-            </a:r>
-          </a:p>
-          <a:p/>
-          <a:p>
-            <a:r>
-              <a:t>ASSESSMENT TIPS:</a:t>
-            </a:r>
-          </a:p>
-          <a:p>
-            <a:r>
-              <a:t>Creative organization.</a:t>
-            </a:r>
-          </a:p>
-          <a:p/>
-          <a:p>
-            <a:r>
-              <a:t>EXTENSION QUESTIONS:</a:t>
-            </a:r>
-          </a:p>
-          <a:p>
-            <a:r>
-              <a:t>Add a cliffhanger ending.</a:t>
-            </a:r>
-          </a:p>
-          <a:p/>
-          <a:p>
-            <a:r>
-              <a:t>TIMING: Storytelling</a:t>
-            </a:r>
-          </a:p>
         </p:txBody>
       </p:sp>
       <p:sp>
@@ -1609,77 +1049,7 @@
         <p:txBody>
           <a:bodyPr/>
           <a:lstStyle/>
-          <a:p>
-            <a:r>
-              <a:t>WHAT TO SAY:</a:t>
-            </a:r>
-          </a:p>
-          <a:p>
-            <a:r>
-              <a:t>Roll dice or pick numbers.</a:t>
-            </a:r>
-          </a:p>
           <a:p/>
-          <a:p>
-            <a:r>
-              <a:t>STUDENT ACTIVITY:</a:t>
-            </a:r>
-          </a:p>
-          <a:p>
-            <a:r>
-              <a:t>Write/say 5–7 sentence story.</a:t>
-            </a:r>
-          </a:p>
-          <a:p/>
-          <a:p>
-            <a:r>
-              <a:t>EXPECTED ANSWERS / RESPONSES:</a:t>
-            </a:r>
-          </a:p>
-          <a:p>
-            <a:r>
-              <a:t>Includes 2+ past perfect verbs.</a:t>
-            </a:r>
-          </a:p>
-          <a:p/>
-          <a:p>
-            <a:r>
-              <a:t>COMMON MISTAKES:</a:t>
-            </a:r>
-          </a:p>
-          <a:p>
-            <a:r>
-              <a:t>Only simple past.</a:t>
-            </a:r>
-          </a:p>
-          <a:p/>
-          <a:p>
-            <a:r>
-              <a:t>ASSESSMENT TIPS:</a:t>
-            </a:r>
-          </a:p>
-          <a:p>
-            <a:r>
-              <a:t>Creative writing + grammar.</a:t>
-            </a:r>
-          </a:p>
-          <a:p/>
-          <a:p>
-            <a:r>
-              <a:t>EXTENSION QUESTIONS:</a:t>
-            </a:r>
-          </a:p>
-          <a:p>
-            <a:r>
-              <a:t>Peer question: What happened first?</a:t>
-            </a:r>
-          </a:p>
-          <a:p/>
-          <a:p>
-            <a:r>
-              <a:t>TIMING: Storytelling 10 min</a:t>
-            </a:r>
-          </a:p>
         </p:txBody>
       </p:sp>
       <p:sp>
@@ -1745,77 +1115,7 @@
         <p:txBody>
           <a:bodyPr/>
           <a:lstStyle/>
-          <a:p>
-            <a:r>
-              <a:t>WHAT TO SAY:</a:t>
-            </a:r>
-          </a:p>
-          <a:p>
-            <a:r>
-              <a:t>Fast quiz—celebrate streaks.</a:t>
-            </a:r>
-          </a:p>
           <a:p/>
-          <a:p>
-            <a:r>
-              <a:t>STUDENT ACTIVITY:</a:t>
-            </a:r>
-          </a:p>
-          <a:p>
-            <a:r>
-              <a:t>Verbal answers.</a:t>
-            </a:r>
-          </a:p>
-          <a:p/>
-          <a:p>
-            <a:r>
-              <a:t>EXPECTED ANSWERS / RESPONSES:</a:t>
-            </a:r>
-          </a:p>
-          <a:p>
-            <a:r>
-              <a:t>participle; before; had eaten; had finished; had left</a:t>
-            </a:r>
-          </a:p>
-          <a:p/>
-          <a:p>
-            <a:r>
-              <a:t>COMMON MISTAKES:</a:t>
-            </a:r>
-          </a:p>
-          <a:p>
-            <a:r>
-              <a:t>Panicking—slow down.</a:t>
-            </a:r>
-          </a:p>
-          <a:p/>
-          <a:p>
-            <a:r>
-              <a:t>ASSESSMENT TIPS:</a:t>
-            </a:r>
-          </a:p>
-          <a:p>
-            <a:r>
-              <a:t>Quick recall.</a:t>
-            </a:r>
-          </a:p>
-          <a:p/>
-          <a:p>
-            <a:r>
-              <a:t>EXTENSION QUESTIONS:</a:t>
-            </a:r>
-          </a:p>
-          <a:p>
-            <a:r>
-              <a:t>Make Q6.</a:t>
-            </a:r>
-          </a:p>
-          <a:p/>
-          <a:p>
-            <a:r>
-              <a:t>TIMING: Games</a:t>
-            </a:r>
-          </a:p>
         </p:txBody>
       </p:sp>
       <p:sp>
@@ -1881,77 +1181,7 @@
         <p:txBody>
           <a:bodyPr/>
           <a:lstStyle/>
-          <a:p>
-            <a:r>
-              <a:t>WHAT TO SAY:</a:t>
-            </a:r>
-          </a:p>
-          <a:p>
-            <a:r>
-              <a:t>Timer 5 min escape.</a:t>
-            </a:r>
-          </a:p>
           <a:p/>
-          <a:p>
-            <a:r>
-              <a:t>STUDENT ACTIVITY:</a:t>
-            </a:r>
-          </a:p>
-          <a:p>
-            <a:r>
-              <a:t>Solve all clues aloud.</a:t>
-            </a:r>
-          </a:p>
-          <a:p/>
-          <a:p>
-            <a:r>
-              <a:t>EXPECTED ANSWERS / RESPONSES:</a:t>
-            </a:r>
-          </a:p>
-          <a:p>
-            <a:r>
-              <a:t>Clue 1 past perfect; 2 gone; 3 quest; 4 had finished; 5 Jordan</a:t>
-            </a:r>
-          </a:p>
-          <a:p/>
-          <a:p>
-            <a:r>
-              <a:t>COMMON MISTAKES:</a:t>
-            </a:r>
-          </a:p>
-          <a:p>
-            <a:r>
-              <a:t>Stuck—offer hint.</a:t>
-            </a:r>
-          </a:p>
-          <a:p/>
-          <a:p>
-            <a:r>
-              <a:t>ASSESSMENT TIPS:</a:t>
-            </a:r>
-          </a:p>
-          <a:p>
-            <a:r>
-              <a:t>Integrated skills.</a:t>
-            </a:r>
-          </a:p>
-          <a:p/>
-          <a:p>
-            <a:r>
-              <a:t>EXTENSION QUESTIONS:</a:t>
-            </a:r>
-          </a:p>
-          <a:p>
-            <a:r>
-              <a:t>Design a Clue 6.</a:t>
-            </a:r>
-          </a:p>
-          <a:p/>
-          <a:p>
-            <a:r>
-              <a:t>TIMING: Games / recap transition</a:t>
-            </a:r>
-          </a:p>
         </p:txBody>
       </p:sp>
       <p:sp>
@@ -2017,77 +1247,7 @@
         <p:txBody>
           <a:bodyPr/>
           <a:lstStyle/>
-          <a:p>
-            <a:r>
-              <a:t>WHAT TO SAY:</a:t>
-            </a:r>
-          </a:p>
-          <a:p>
-            <a:r>
-              <a:t>Do 4–6 pairs quickly.</a:t>
-            </a:r>
-          </a:p>
           <a:p/>
-          <a:p>
-            <a:r>
-              <a:t>STUDENT ACTIVITY:</a:t>
-            </a:r>
-          </a:p>
-          <a:p>
-            <a:r>
-              <a:t>Choose + because…</a:t>
-            </a:r>
-          </a:p>
-          <a:p/>
-          <a:p>
-            <a:r>
-              <a:t>EXPECTED ANSWERS / RESPONSES:</a:t>
-            </a:r>
-          </a:p>
-          <a:p>
-            <a:r>
-              <a:t>Full sentences with reasons.</a:t>
-            </a:r>
-          </a:p>
-          <a:p/>
-          <a:p>
-            <a:r>
-              <a:t>COMMON MISTAKES:</a:t>
-            </a:r>
-          </a:p>
-          <a:p>
-            <a:r>
-              <a:t>One-word answers.</a:t>
-            </a:r>
-          </a:p>
-          <a:p/>
-          <a:p>
-            <a:r>
-              <a:t>ASSESSMENT TIPS:</a:t>
-            </a:r>
-          </a:p>
-          <a:p>
-            <a:r>
-              <a:t>Speaking fluency, preferences.</a:t>
-            </a:r>
-          </a:p>
-          <a:p/>
-          <a:p>
-            <a:r>
-              <a:t>EXTENSION QUESTIONS:</a:t>
-            </a:r>
-          </a:p>
-          <a:p>
-            <a:r>
-              <a:t>Would your choice change on weekends?</a:t>
-            </a:r>
-          </a:p>
-          <a:p/>
-          <a:p>
-            <a:r>
-              <a:t>TIMING: 5 min icebreaker</a:t>
-            </a:r>
-          </a:p>
         </p:txBody>
       </p:sp>
       <p:sp>
@@ -2153,77 +1313,7 @@
         <p:txBody>
           <a:bodyPr/>
           <a:lstStyle/>
-          <a:p>
-            <a:r>
-              <a:t>WHAT TO SAY:</a:t>
-            </a:r>
-          </a:p>
-          <a:p>
-            <a:r>
-              <a:t>Student-led recap 2 minutes.</a:t>
-            </a:r>
-          </a:p>
           <a:p/>
-          <a:p>
-            <a:r>
-              <a:t>STUDENT ACTIVITY:</a:t>
-            </a:r>
-          </a:p>
-          <a:p>
-            <a:r>
-              <a:t>Teach back key ideas.</a:t>
-            </a:r>
-          </a:p>
-          <a:p/>
-          <a:p>
-            <a:r>
-              <a:t>EXPECTED ANSWERS / RESPONSES:</a:t>
-            </a:r>
-          </a:p>
-          <a:p>
-            <a:r>
-              <a:t>Accurate mini-lesson.</a:t>
-            </a:r>
-          </a:p>
-          <a:p/>
-          <a:p>
-            <a:r>
-              <a:t>COMMON MISTAKES:</a:t>
-            </a:r>
-          </a:p>
-          <a:p>
-            <a:r>
-              <a:t>Minimal response—prompt examples.</a:t>
-            </a:r>
-          </a:p>
-          <a:p/>
-          <a:p>
-            <a:r>
-              <a:t>ASSESSMENT TIPS:</a:t>
-            </a:r>
-          </a:p>
-          <a:p>
-            <a:r>
-              <a:t>Metacognition + retention.</a:t>
-            </a:r>
-          </a:p>
-          <a:p/>
-          <a:p>
-            <a:r>
-              <a:t>EXTENSION QUESTIONS:</a:t>
-            </a:r>
-          </a:p>
-          <a:p>
-            <a:r>
-              <a:t>One goal for next week?</a:t>
-            </a:r>
-          </a:p>
-          <a:p/>
-          <a:p>
-            <a:r>
-              <a:t>TIMING: 5 min recap</a:t>
-            </a:r>
-          </a:p>
         </p:txBody>
       </p:sp>
       <p:sp>
@@ -2289,77 +1379,7 @@
         <p:txBody>
           <a:bodyPr/>
           <a:lstStyle/>
-          <a:p>
-            <a:r>
-              <a:t>WHAT TO SAY:</a:t>
-            </a:r>
-          </a:p>
-          <a:p>
-            <a:r>
-              <a:t>Explain clearly; show example starter.</a:t>
-            </a:r>
-          </a:p>
           <a:p/>
-          <a:p>
-            <a:r>
-              <a:t>STUDENT ACTIVITY:</a:t>
-            </a:r>
-          </a:p>
-          <a:p>
-            <a:r>
-              <a:t>Plan 3 bullet points before writing.</a:t>
-            </a:r>
-          </a:p>
-          <a:p/>
-          <a:p>
-            <a:r>
-              <a:t>EXPECTED ANSWERS / RESPONSES:</a:t>
-            </a:r>
-          </a:p>
-          <a:p>
-            <a:r>
-              <a:t>Meets length + grammar + vocab requirements.</a:t>
-            </a:r>
-          </a:p>
-          <a:p/>
-          <a:p>
-            <a:r>
-              <a:t>COMMON MISTAKES:</a:t>
-            </a:r>
-          </a:p>
-          <a:p>
-            <a:r>
-              <a:t>All simple past.</a:t>
-            </a:r>
-          </a:p>
-          <a:p/>
-          <a:p>
-            <a:r>
-              <a:t>ASSESSMENT TIPS:</a:t>
-            </a:r>
-          </a:p>
-          <a:p>
-            <a:r>
-              <a:t>Transfer to independent work.</a:t>
-            </a:r>
-          </a:p>
-          <a:p/>
-          <a:p>
-            <a:r>
-              <a:t>EXTENSION QUESTIONS:</a:t>
-            </a:r>
-          </a:p>
-          <a:p>
-            <a:r>
-              <a:t>Email/share next class optional.</a:t>
-            </a:r>
-          </a:p>
-          <a:p/>
-          <a:p>
-            <a:r>
-              <a:t>TIMING: Homework</a:t>
-            </a:r>
-          </a:p>
         </p:txBody>
       </p:sp>
       <p:sp>
@@ -2425,77 +1445,7 @@
         <p:txBody>
           <a:bodyPr/>
           <a:lstStyle/>
-          <a:p>
-            <a:r>
-              <a:t>WHAT TO SAY:</a:t>
-            </a:r>
-          </a:p>
-          <a:p>
-            <a:r>
-              <a:t>Specific praise (2 strengths).</a:t>
-            </a:r>
-          </a:p>
           <a:p/>
-          <a:p>
-            <a:r>
-              <a:t>STUDENT ACTIVITY:</a:t>
-            </a:r>
-          </a:p>
-          <a:p>
-            <a:r>
-              <a:t>Student shares proudest moment.</a:t>
-            </a:r>
-          </a:p>
-          <a:p/>
-          <a:p>
-            <a:r>
-              <a:t>EXPECTED ANSWERS / RESPONSES:</a:t>
-            </a:r>
-          </a:p>
-          <a:p>
-            <a:r>
-              <a:t>Positive closure.</a:t>
-            </a:r>
-          </a:p>
-          <a:p/>
-          <a:p>
-            <a:r>
-              <a:t>COMMON MISTAKES:</a:t>
-            </a:r>
-          </a:p>
-          <a:p>
-            <a:r>
-              <a:t>Generic praise only.</a:t>
-            </a:r>
-          </a:p>
-          <a:p/>
-          <a:p>
-            <a:r>
-              <a:t>ASSESSMENT TIPS:</a:t>
-            </a:r>
-          </a:p>
-          <a:p>
-            <a:r>
-              <a:t>End energy high for parents.</a:t>
-            </a:r>
-          </a:p>
-          <a:p/>
-          <a:p>
-            <a:r>
-              <a:t>EXTENSION QUESTIONS:</a:t>
-            </a:r>
-          </a:p>
-          <a:p>
-            <a:r>
-              <a:t>Preview next topic.</a:t>
-            </a:r>
-          </a:p>
-          <a:p/>
-          <a:p>
-            <a:r>
-              <a:t>TIMING: End</a:t>
-            </a:r>
-          </a:p>
         </p:txBody>
       </p:sp>
       <p:sp>
@@ -2561,77 +1511,7 @@
         <p:txBody>
           <a:bodyPr/>
           <a:lstStyle/>
-          <a:p>
-            <a:r>
-              <a:t>WHAT TO SAY:</a:t>
-            </a:r>
-          </a:p>
-          <a:p>
-            <a:r>
-              <a:t>Cover hints; student guesses word/idea.</a:t>
-            </a:r>
-          </a:p>
           <a:p/>
-          <a:p>
-            <a:r>
-              <a:t>STUDENT ACTIVITY:</a:t>
-            </a:r>
-          </a:p>
-          <a:p>
-            <a:r>
-              <a:t>Match emoji to hint; say a sentence.</a:t>
-            </a:r>
-          </a:p>
-          <a:p/>
-          <a:p>
-            <a:r>
-              <a:t>EXPECTED ANSWERS / RESPONSES:</a:t>
-            </a:r>
-          </a:p>
-          <a:p>
-            <a:r>
-              <a:t>library, key, door, echo, realize, map (accept close).</a:t>
-            </a:r>
-          </a:p>
-          <a:p/>
-          <a:p>
-            <a:r>
-              <a:t>COMMON MISTAKES:</a:t>
-            </a:r>
-          </a:p>
-          <a:p>
-            <a:r>
-              <a:t>Random guesses—give second clue.</a:t>
-            </a:r>
-          </a:p>
-          <a:p/>
-          <a:p>
-            <a:r>
-              <a:t>ASSESSMENT TIPS:</a:t>
-            </a:r>
-          </a:p>
-          <a:p>
-            <a:r>
-              <a:t>Quick listening + vocabulary warm-up.</a:t>
-            </a:r>
-          </a:p>
-          <a:p/>
-          <a:p>
-            <a:r>
-              <a:t>EXTENSION QUESTIONS:</a:t>
-            </a:r>
-          </a:p>
-          <a:p>
-            <a:r>
-              <a:t>Link to today's library story.</a:t>
-            </a:r>
-          </a:p>
-          <a:p/>
-          <a:p>
-            <a:r>
-              <a:t>TIMING: 5 min</a:t>
-            </a:r>
-          </a:p>
         </p:txBody>
       </p:sp>
       <p:sp>
@@ -2697,77 +1577,7 @@
         <p:txBody>
           <a:bodyPr/>
           <a:lstStyle/>
-          <a:p>
-            <a:r>
-              <a:t>WHAT TO SAY:</a:t>
-            </a:r>
-          </a:p>
-          <a:p>
-            <a:r>
-              <a:t>Quick tour—student repeats one goal in own words.</a:t>
-            </a:r>
-          </a:p>
           <a:p/>
-          <a:p>
-            <a:r>
-              <a:t>STUDENT ACTIVITY:</a:t>
-            </a:r>
-          </a:p>
-          <a:p>
-            <a:r>
-              <a:t>Which goal excites you most?</a:t>
-            </a:r>
-          </a:p>
-          <a:p/>
-          <a:p>
-            <a:r>
-              <a:t>EXPECTED ANSWERS / RESPONSES:</a:t>
-            </a:r>
-          </a:p>
-          <a:p>
-            <a:r>
-              <a:t>Student picks goal; shows motivation.</a:t>
-            </a:r>
-          </a:p>
-          <a:p/>
-          <a:p>
-            <a:r>
-              <a:t>COMMON MISTAKES:</a:t>
-            </a:r>
-          </a:p>
-          <a:p>
-            <a:r>
-              <a:t>Disengagement—connect to games.</a:t>
-            </a:r>
-          </a:p>
-          <a:p/>
-          <a:p>
-            <a:r>
-              <a:t>ASSESSMENT TIPS:</a:t>
-            </a:r>
-          </a:p>
-          <a:p>
-            <a:r>
-              <a:t>Goal-setting buy-in.</a:t>
-            </a:r>
-          </a:p>
-          <a:p/>
-          <a:p>
-            <a:r>
-              <a:t>EXTENSION QUESTIONS:</a:t>
-            </a:r>
-          </a:p>
-          <a:p>
-            <a:r>
-              <a:t>How will you know you improved today?</a:t>
-            </a:r>
-          </a:p>
-          <a:p/>
-          <a:p>
-            <a:r>
-              <a:t>TIMING: 1 min</a:t>
-            </a:r>
-          </a:p>
         </p:txBody>
       </p:sp>
       <p:sp>
@@ -2833,77 +1643,7 @@
         <p:txBody>
           <a:bodyPr/>
           <a:lstStyle/>
-          <a:p>
-            <a:r>
-              <a:t>WHAT TO SAY:</a:t>
-            </a:r>
-          </a:p>
-          <a:p>
-            <a:r>
-              <a:t>Teach with timeline gesture: earlier ← had ___, later ← simple past.</a:t>
-            </a:r>
-          </a:p>
           <a:p/>
-          <a:p>
-            <a:r>
-              <a:t>STUDENT ACTIVITY:</a:t>
-            </a:r>
-          </a:p>
-          <a:p>
-            <a:r>
-              <a:t>Repeat structure; create 1 sentence about school day.</a:t>
-            </a:r>
-          </a:p>
-          <a:p/>
-          <a:p>
-            <a:r>
-              <a:t>EXPECTED ANSWERS / RESPONSES:</a:t>
-            </a:r>
-          </a:p>
-          <a:p>
-            <a:r>
-              <a:t>Sample: I had finished homework before dinner.</a:t>
-            </a:r>
-          </a:p>
-          <a:p/>
-          <a:p>
-            <a:r>
-              <a:t>COMMON MISTAKES:</a:t>
-            </a:r>
-          </a:p>
-          <a:p>
-            <a:r>
-              <a:t>had + past tense (had went).</a:t>
-            </a:r>
-          </a:p>
-          <a:p/>
-          <a:p>
-            <a:r>
-              <a:t>ASSESSMENT TIPS:</a:t>
-            </a:r>
-          </a:p>
-          <a:p>
-            <a:r>
-              <a:t>Conceptual grasp of sequence in past.</a:t>
-            </a:r>
-          </a:p>
-          <a:p/>
-          <a:p>
-            <a:r>
-              <a:t>EXTENSION QUESTIONS:</a:t>
-            </a:r>
-          </a:p>
-          <a:p>
-            <a:r>
-              <a:t>What happened first in: 'After I had locked the door, I left'?</a:t>
-            </a:r>
-          </a:p>
-          <a:p/>
-          <a:p>
-            <a:r>
-              <a:t>TIMING: Grammar 15 min start</a:t>
-            </a:r>
-          </a:p>
         </p:txBody>
       </p:sp>
       <p:sp>
@@ -2969,77 +1709,7 @@
         <p:txBody>
           <a:bodyPr/>
           <a:lstStyle/>
-          <a:p>
-            <a:r>
-              <a:t>WHAT TO SAY:</a:t>
-            </a:r>
-          </a:p>
-          <a:p>
-            <a:r>
-              <a:t>Point to timeline left-to-right.</a:t>
-            </a:r>
-          </a:p>
           <a:p/>
-          <a:p>
-            <a:r>
-              <a:t>STUDENT ACTIVITY:</a:t>
-            </a:r>
-          </a:p>
-          <a:p>
-            <a:r>
-              <a:t>Label which sentences need Past Perfect.</a:t>
-            </a:r>
-          </a:p>
-          <a:p/>
-          <a:p>
-            <a:r>
-              <a:t>EXPECTED ANSWERS / RESPONSES:</a:t>
-            </a:r>
-          </a:p>
-          <a:p>
-            <a:r>
-              <a:t>1–2 Past Perfect; 3–4 simple past.</a:t>
-            </a:r>
-          </a:p>
-          <a:p/>
-          <a:p>
-            <a:r>
-              <a:t>COMMON MISTAKES:</a:t>
-            </a:r>
-          </a:p>
-          <a:p>
-            <a:r>
-              <a:t>Marking later events as past perfect.</a:t>
-            </a:r>
-          </a:p>
-          <a:p/>
-          <a:p>
-            <a:r>
-              <a:t>ASSESSMENT TIPS:</a:t>
-            </a:r>
-          </a:p>
-          <a:p>
-            <a:r>
-              <a:t>Sequence understanding.</a:t>
-            </a:r>
-          </a:p>
-          <a:p/>
-          <a:p>
-            <a:r>
-              <a:t>EXTENSION QUESTIONS:</a:t>
-            </a:r>
-          </a:p>
-          <a:p>
-            <a:r>
-              <a:t>Rewrite #3 using past perfect for earlier action.</a:t>
-            </a:r>
-          </a:p>
-          <a:p/>
-          <a:p>
-            <a:r>
-              <a:t>TIMING: Grammar block</a:t>
-            </a:r>
-          </a:p>
         </p:txBody>
       </p:sp>
       <p:sp>
@@ -3105,77 +1775,7 @@
         <p:txBody>
           <a:bodyPr/>
           <a:lstStyle/>
-          <a:p>
-            <a:r>
-              <a:t>WHAT TO SAY:</a:t>
-            </a:r>
-          </a:p>
-          <a:p>
-            <a:r>
-              <a:t>Think aloud #1.</a:t>
-            </a:r>
-          </a:p>
           <a:p/>
-          <a:p>
-            <a:r>
-              <a:t>STUDENT ACTIVITY:</a:t>
-            </a:r>
-          </a:p>
-          <a:p>
-            <a:r>
-              <a:t>Say answers aloud.</a:t>
-            </a:r>
-          </a:p>
-          <a:p/>
-          <a:p>
-            <a:r>
-              <a:t>EXPECTED ANSWERS / RESPONSES:</a:t>
-            </a:r>
-          </a:p>
-          <a:p>
-            <a:r>
-              <a:t>had finished; had never seen; had opened; had already left; realized (or had realized if before another past event—accept had realized)</a:t>
-            </a:r>
-          </a:p>
-          <a:p/>
-          <a:p>
-            <a:r>
-              <a:t>COMMON MISTAKES:</a:t>
-            </a:r>
-          </a:p>
-          <a:p>
-            <a:r>
-              <a:t>For #5 accept simple past realized as main event.</a:t>
-            </a:r>
-          </a:p>
-          <a:p/>
-          <a:p>
-            <a:r>
-              <a:t>ASSESSMENT TIPS:</a:t>
-            </a:r>
-          </a:p>
-          <a:p>
-            <a:r>
-              <a:t>Form accuracy.</a:t>
-            </a:r>
-          </a:p>
-          <a:p/>
-          <a:p>
-            <a:r>
-              <a:t>EXTENSION QUESTIONS:</a:t>
-            </a:r>
-          </a:p>
-          <a:p>
-            <a:r>
-              <a:t>Write your own sentence using 'before'.</a:t>
-            </a:r>
-          </a:p>
-          <a:p/>
-          <a:p>
-            <a:r>
-              <a:t>TIMING: Grammar</a:t>
-            </a:r>
-          </a:p>
         </p:txBody>
       </p:sp>
       <p:sp>
@@ -3241,77 +1841,7 @@
         <p:txBody>
           <a:bodyPr/>
           <a:lstStyle/>
-          <a:p>
-            <a:r>
-              <a:t>WHAT TO SAY:</a:t>
-            </a:r>
-          </a:p>
-          <a:p>
-            <a:r>
-              <a:t>Lightning detective game.</a:t>
-            </a:r>
-          </a:p>
           <a:p/>
-          <a:p>
-            <a:r>
-              <a:t>STUDENT ACTIVITY:</a:t>
-            </a:r>
-          </a:p>
-          <a:p>
-            <a:r>
-              <a:t>Fix or say 'Correct!'</a:t>
-            </a:r>
-          </a:p>
-          <a:p/>
-          <a:p>
-            <a:r>
-              <a:t>EXPECTED ANSWERS / RESPONSES:</a:t>
-            </a:r>
-          </a:p>
-          <a:p>
-            <a:r>
-              <a:t>1 had gone 2 OK 3 flickered 4 OK 5 had left</a:t>
-            </a:r>
-          </a:p>
-          <a:p/>
-          <a:p>
-            <a:r>
-              <a:t>COMMON MISTAKES:</a:t>
-            </a:r>
-          </a:p>
-          <a:p>
-            <a:r>
-              <a:t>Changing correct sentences.</a:t>
-            </a:r>
-          </a:p>
-          <a:p/>
-          <a:p>
-            <a:r>
-              <a:t>ASSESSMENT TIPS:</a:t>
-            </a:r>
-          </a:p>
-          <a:p>
-            <a:r>
-              <a:t>Error detection.</a:t>
-            </a:r>
-          </a:p>
-          <a:p/>
-          <a:p>
-            <a:r>
-              <a:t>EXTENSION QUESTIONS:</a:t>
-            </a:r>
-          </a:p>
-          <a:p>
-            <a:r>
-              <a:t>Create one mistake for teacher.</a:t>
-            </a:r>
-          </a:p>
-          <a:p/>
-          <a:p>
-            <a:r>
-              <a:t>TIMING: 5 min grammar game</a:t>
-            </a:r>
-          </a:p>
         </p:txBody>
       </p:sp>
       <p:sp>
@@ -3377,77 +1907,7 @@
         <p:txBody>
           <a:bodyPr/>
           <a:lstStyle/>
-          <a:p>
-            <a:r>
-              <a:t>WHAT TO SAY:</a:t>
-            </a:r>
-          </a:p>
-          <a:p>
-            <a:r>
-              <a:t>Read with suspense. Highlight past perfect forms.</a:t>
-            </a:r>
-          </a:p>
           <a:p/>
-          <a:p>
-            <a:r>
-              <a:t>STUDENT ACTIVITY:</a:t>
-            </a:r>
-          </a:p>
-          <a:p>
-            <a:r>
-              <a:t>Listen; then student reads one paragraph.</a:t>
-            </a:r>
-          </a:p>
-          <a:p/>
-          <a:p>
-            <a:r>
-              <a:t>EXPECTED ANSWERS / RESPONSES:</a:t>
-            </a:r>
-          </a:p>
-          <a:p>
-            <a:r>
-              <a:t>Follows plot; notices had + participle.</a:t>
-            </a:r>
-          </a:p>
-          <a:p/>
-          <a:p>
-            <a:r>
-              <a:t>COMMON MISTAKES:</a:t>
-            </a:r>
-          </a:p>
-          <a:p>
-            <a:r>
-              <a:t>Losing track—pause to summarize.</a:t>
-            </a:r>
-          </a:p>
-          <a:p/>
-          <a:p>
-            <a:r>
-              <a:t>ASSESSMENT TIPS:</a:t>
-            </a:r>
-          </a:p>
-          <a:p>
-            <a:r>
-              <a:t>Fluency + engagement.</a:t>
-            </a:r>
-          </a:p>
-          <a:p/>
-          <a:p>
-            <a:r>
-              <a:t>EXTENSION QUESTIONS:</a:t>
-            </a:r>
-          </a:p>
-          <a:p>
-            <a:r>
-              <a:t>Predict the next chapter.</a:t>
-            </a:r>
-          </a:p>
-          <a:p/>
-          <a:p>
-            <a:r>
-              <a:t>TIMING: Reading ~6 min</a:t>
-            </a:r>
-          </a:p>
         </p:txBody>
       </p:sp>
       <p:sp>

</xml_diff>